<commit_message>
fix chinese font in plotting and edit continuous icon
</commit_message>
<xml_diff>
--- a/icon/design.pptx
+++ b/icon/design.pptx
@@ -261,7 +261,7 @@
           <a:p>
             <a:fld id="{CC7F0EFD-98CC-144B-86FC-2C31795ED826}" type="datetimeFigureOut">
               <a:rPr lang="en-TW" smtClean="0"/>
-              <a:t>2026/4/26</a:t>
+              <a:t>2026/5/1</a:t>
             </a:fld>
             <a:endParaRPr lang="en-TW"/>
           </a:p>
@@ -461,7 +461,7 @@
           <a:p>
             <a:fld id="{CC7F0EFD-98CC-144B-86FC-2C31795ED826}" type="datetimeFigureOut">
               <a:rPr lang="en-TW" smtClean="0"/>
-              <a:t>2026/4/26</a:t>
+              <a:t>2026/5/1</a:t>
             </a:fld>
             <a:endParaRPr lang="en-TW"/>
           </a:p>
@@ -671,7 +671,7 @@
           <a:p>
             <a:fld id="{CC7F0EFD-98CC-144B-86FC-2C31795ED826}" type="datetimeFigureOut">
               <a:rPr lang="en-TW" smtClean="0"/>
-              <a:t>2026/4/26</a:t>
+              <a:t>2026/5/1</a:t>
             </a:fld>
             <a:endParaRPr lang="en-TW"/>
           </a:p>
@@ -871,7 +871,7 @@
           <a:p>
             <a:fld id="{CC7F0EFD-98CC-144B-86FC-2C31795ED826}" type="datetimeFigureOut">
               <a:rPr lang="en-TW" smtClean="0"/>
-              <a:t>2026/4/26</a:t>
+              <a:t>2026/5/1</a:t>
             </a:fld>
             <a:endParaRPr lang="en-TW"/>
           </a:p>
@@ -1147,7 +1147,7 @@
           <a:p>
             <a:fld id="{CC7F0EFD-98CC-144B-86FC-2C31795ED826}" type="datetimeFigureOut">
               <a:rPr lang="en-TW" smtClean="0"/>
-              <a:t>2026/4/26</a:t>
+              <a:t>2026/5/1</a:t>
             </a:fld>
             <a:endParaRPr lang="en-TW"/>
           </a:p>
@@ -1415,7 +1415,7 @@
           <a:p>
             <a:fld id="{CC7F0EFD-98CC-144B-86FC-2C31795ED826}" type="datetimeFigureOut">
               <a:rPr lang="en-TW" smtClean="0"/>
-              <a:t>2026/4/26</a:t>
+              <a:t>2026/5/1</a:t>
             </a:fld>
             <a:endParaRPr lang="en-TW"/>
           </a:p>
@@ -1830,7 +1830,7 @@
           <a:p>
             <a:fld id="{CC7F0EFD-98CC-144B-86FC-2C31795ED826}" type="datetimeFigureOut">
               <a:rPr lang="en-TW" smtClean="0"/>
-              <a:t>2026/4/26</a:t>
+              <a:t>2026/5/1</a:t>
             </a:fld>
             <a:endParaRPr lang="en-TW"/>
           </a:p>
@@ -1972,7 +1972,7 @@
           <a:p>
             <a:fld id="{CC7F0EFD-98CC-144B-86FC-2C31795ED826}" type="datetimeFigureOut">
               <a:rPr lang="en-TW" smtClean="0"/>
-              <a:t>2026/4/26</a:t>
+              <a:t>2026/5/1</a:t>
             </a:fld>
             <a:endParaRPr lang="en-TW"/>
           </a:p>
@@ -2085,7 +2085,7 @@
           <a:p>
             <a:fld id="{CC7F0EFD-98CC-144B-86FC-2C31795ED826}" type="datetimeFigureOut">
               <a:rPr lang="en-TW" smtClean="0"/>
-              <a:t>2026/4/26</a:t>
+              <a:t>2026/5/1</a:t>
             </a:fld>
             <a:endParaRPr lang="en-TW"/>
           </a:p>
@@ -2398,7 +2398,7 @@
           <a:p>
             <a:fld id="{CC7F0EFD-98CC-144B-86FC-2C31795ED826}" type="datetimeFigureOut">
               <a:rPr lang="en-TW" smtClean="0"/>
-              <a:t>2026/4/26</a:t>
+              <a:t>2026/5/1</a:t>
             </a:fld>
             <a:endParaRPr lang="en-TW"/>
           </a:p>
@@ -2687,7 +2687,7 @@
           <a:p>
             <a:fld id="{CC7F0EFD-98CC-144B-86FC-2C31795ED826}" type="datetimeFigureOut">
               <a:rPr lang="en-TW" smtClean="0"/>
-              <a:t>2026/4/26</a:t>
+              <a:t>2026/5/1</a:t>
             </a:fld>
             <a:endParaRPr lang="en-TW"/>
           </a:p>
@@ -2930,7 +2930,7 @@
           <a:p>
             <a:fld id="{CC7F0EFD-98CC-144B-86FC-2C31795ED826}" type="datetimeFigureOut">
               <a:rPr lang="en-TW" smtClean="0"/>
-              <a:t>2026/4/26</a:t>
+              <a:t>2026/5/1</a:t>
             </a:fld>
             <a:endParaRPr lang="en-TW"/>
           </a:p>
@@ -4951,6 +4951,76 @@
           </p:txBody>
         </p:sp>
       </p:grpSp>
+      <p:sp>
+        <p:nvSpPr>
+          <p:cNvPr id="2" name="Oval 1">
+            <a:extLst>
+              <a:ext uri="{FF2B5EF4-FFF2-40B4-BE49-F238E27FC236}">
+                <a16:creationId xmlns:a16="http://schemas.microsoft.com/office/drawing/2014/main" id="{511DB84E-6FF7-1CFA-234D-F3F3060A6B87}"/>
+              </a:ext>
+            </a:extLst>
+          </p:cNvPr>
+          <p:cNvSpPr/>
+          <p:nvPr/>
+        </p:nvSpPr>
+        <p:spPr>
+          <a:xfrm>
+            <a:off x="4201331" y="3226376"/>
+            <a:ext cx="360000" cy="360000"/>
+          </a:xfrm>
+          <a:prstGeom prst="ellipse">
+            <a:avLst/>
+          </a:prstGeom>
+          <a:gradFill flip="none" rotWithShape="1">
+            <a:gsLst>
+              <a:gs pos="60000">
+                <a:srgbClr val="92D050"/>
+              </a:gs>
+              <a:gs pos="40000">
+                <a:srgbClr val="FFC000"/>
+              </a:gs>
+              <a:gs pos="20000">
+                <a:srgbClr val="FF7E79"/>
+              </a:gs>
+              <a:gs pos="80000">
+                <a:schemeClr val="accent1">
+                  <a:lumMod val="60000"/>
+                  <a:lumOff val="40000"/>
+                </a:schemeClr>
+              </a:gs>
+            </a:gsLst>
+            <a:lin ang="1800000" scaled="0"/>
+            <a:tileRect/>
+          </a:gradFill>
+          <a:ln>
+            <a:noFill/>
+          </a:ln>
+        </p:spPr>
+        <p:style>
+          <a:lnRef idx="2">
+            <a:schemeClr val="accent1">
+              <a:shade val="15000"/>
+            </a:schemeClr>
+          </a:lnRef>
+          <a:fillRef idx="1">
+            <a:schemeClr val="accent1"/>
+          </a:fillRef>
+          <a:effectRef idx="0">
+            <a:schemeClr val="accent1"/>
+          </a:effectRef>
+          <a:fontRef idx="minor">
+            <a:schemeClr val="lt1"/>
+          </a:fontRef>
+        </p:style>
+        <p:txBody>
+          <a:bodyPr rtlCol="0" anchor="ctr"/>
+          <a:lstStyle/>
+          <a:p>
+            <a:pPr algn="ctr"/>
+            <a:endParaRPr lang="en-TW" dirty="0"/>
+          </a:p>
+        </p:txBody>
+      </p:sp>
     </p:spTree>
     <p:extLst>
       <p:ext uri="{BB962C8B-B14F-4D97-AF65-F5344CB8AC3E}">

</xml_diff>